<commit_message>
docs: rewrite report, slides and script in B2-level English
Co-Authored-By: Claude Opus 5.5 <noreply@anthropic.com>
Claude-Session: https://claude.ai/code/session_016B3AfV9mnbgXmRzAVLGEiT
</commit_message>
<xml_diff>
--- a/report/presentation.pptx
+++ b/report/presentation.pptx
@@ -118,38 +118,38 @@
   <p:extLst>
     <p:ext uri="{521415D9-36F7-43E2-AB2F-B90AF26B5E84}">
       <p14:sectionLst xmlns:p14="http://schemas.microsoft.com/office/powerpoint/2010/main">
-        <p14:section name="Opening" id="{614aad71-0d2f-a5c2-ac54-9dd84e1f107f}">
+        <p14:section name="Opening" id="{bbee04c2-1ec2-76ac-7689-974e5e9e2904}">
           <p14:sldIdLst>
             <p14:sldId id="256"/>
           </p14:sldIdLst>
         </p14:section>
-        <p14:section name="Context" id="{3107c312-559a-afaa-75bc-0c80b9063319}">
+        <p14:section name="Context" id="{b6b77f16-860b-4d24-3214-57f58d3b9be9}">
           <p14:sldIdLst>
             <p14:sldId id="257"/>
             <p14:sldId id="258"/>
             <p14:sldId id="259"/>
           </p14:sldIdLst>
         </p14:section>
-        <p14:section name="Solution" id="{b3cca349-d7ca-7435-f37c-16a9cf6fb68f}">
+        <p14:section name="Solution" id="{adad0f96-beeb-f56d-dc10-f140c3942452}">
           <p14:sldIdLst>
             <p14:sldId id="260"/>
             <p14:sldId id="261"/>
             <p14:sldId id="262"/>
           </p14:sldIdLst>
         </p14:section>
-        <p14:section name="Hard part" id="{a7a00222-03df-c221-5acd-2a80124e208c}">
+        <p14:section name="Hard part" id="{23d96f43-e1f8-fd4d-2e8c-a7aba4087236}">
           <p14:sldIdLst>
             <p14:sldId id="263"/>
             <p14:sldId id="264"/>
           </p14:sldIdLst>
         </p14:section>
-        <p14:section name="Journey" id="{b507da08-0e7c-ee31-1407-ea7e71134d17}">
+        <p14:section name="Journey" id="{8b3869c0-8758-cd91-a51f-cf6fd06263cd}">
           <p14:sldIdLst>
             <p14:sldId id="265"/>
             <p14:sldId id="266"/>
           </p14:sldIdLst>
         </p14:section>
-        <p14:section name="Closing" id="{a921c2a5-a2e8-7ba8-d161-c98c460637a3}">
+        <p14:section name="Closing" id="{bf82fec8-4145-a5d0-6c44-2e1ca14d8a33}">
           <p14:sldIdLst>
             <p14:sldId id="267"/>
           </p14:sldIdLst>
@@ -558,7 +558,7 @@
           <a:p>
             <a:r>
               <a:rPr lang="en-US" dirty="0"/>
-              <a:t>Good morning, everyone. My name is [your name]. Today, I would like to tell you about a project that I have worked on: a course registration system for university students. I will explain why I built it, what it does, the biggest challenges I faced, and what I learned along the way.</a:t>
+              <a:t>Good morning, everyone. My name is [your name]. Today, I would like to tell you about a project that I have worked on. It is a website that helps university students register for their classes. I will explain why I built it, what it does, the biggest problems I had, and what I have learned.</a:t>
             </a:r>
             <a:endParaRPr lang="en-US" dirty="0"/>
           </a:p>
@@ -646,7 +646,7 @@
           <a:p>
             <a:r>
               <a:rPr lang="en-US" dirty="0"/>
-              <a:t>Now, let me briefly describe how I built the project. I worked in five stages. In January, I analysed the real process and wrote down nine rules. In March, I built the database and the back end, then reorganised the code, built the two websites, and finally prepared the release with Docker and documentation. I used Git the whole time, so I could always go back if I made a mistake.</a:t>
+              <a:t>Now, let me quickly explain how I built the project. I divided the work into five stages. In January, I looked at how registration works at my university, and I wrote down nine rules. In March, I built the database and the back end. Then I reorganised the code, built the two websites, and finally I set up Docker and wrote the guides. I used Git during the whole project, so I could always go back if I made a mistake.</a:t>
             </a:r>
             <a:endParaRPr lang="en-US" dirty="0"/>
           </a:p>
@@ -734,7 +734,7 @@
           <a:p>
             <a:r>
               <a:rPr lang="en-US" dirty="0"/>
-              <a:t>Finally, what did I learn? Of course, I improved my technical skills. But more importantly, I learned four skills that are useful in any job. First, plan before acting: writing the rules first saved me a lot of time. Second, learn independently: many answers were only in English documentation. Third, write clearly: writing documentation taught me to explain ideas simply. And fourth, manage my time by working in small stages. In the future, I would like to add automatic tests, a waiting list, and a prerequisite check.</a:t>
+              <a:t>Finally, what have I learned? Of course, my technical skills have improved a lot. But I think the most useful things are four skills that I can use in any job. First, plan before doing: writing the rules first saved me a lot of time. Second, learn by myself: I found many answers in English guides. Third, write clearly: writing guides taught me to explain ideas in a simple way. And fourth, manage my time by working in small stages. In the future, I would like to add automatic tests, a waiting list and a check for required courses.</a:t>
             </a:r>
             <a:endParaRPr lang="en-US" dirty="0"/>
           </a:p>
@@ -822,7 +822,7 @@
           <a:p>
             <a:r>
               <a:rPr lang="en-US" dirty="0"/>
-              <a:t>To sum up, this project started from a problem I experienced myself and became a complete, working system. It taught me that good software is not only about code, but about understanding people's problems. Thank you very much for listening. I would be happy to answer any questions you may have.</a:t>
+              <a:t>To sum up, this project started from a problem that I had as a student, and it became a complete system that really works. It has taught me that good software is not only about code. It is also about understanding people's problems. Thank you very much for listening. I would be happy to answer any questions you have.</a:t>
             </a:r>
             <a:endParaRPr lang="en-US" dirty="0"/>
           </a:p>
@@ -910,7 +910,7 @@
           <a:p>
             <a:r>
               <a:rPr lang="en-US" dirty="0"/>
-              <a:t>My presentation is divided into four parts. First, I will talk about why I chose this project. Second, I will show you what the system does and how it works. Third, I will focus on the two hardest problems I had to solve. And finally, I will share what I learned. The presentation will take about eight minutes, and I will be happy to answer your questions at the end.</a:t>
+              <a:t>My presentation has four parts. First, I will talk about why I chose this project. Second, I will show you what the system does and how it works. Third, I will talk about the two most difficult problems that I had to solve. And finally, I will tell you what I have learned. My talk will take about eight minutes, and after that I will be happy to answer your questions.</a:t>
             </a:r>
             <a:endParaRPr lang="en-US" dirty="0"/>
           </a:p>
@@ -998,7 +998,7 @@
           <a:p>
             <a:r>
               <a:rPr lang="en-US" dirty="0"/>
-              <a:t>Let me start with the problem. I am sure many of you remember registration day. Everyone clicks at the same time, so seats disappear in minutes. It is easy to choose two classes that are at the same time. The registration period is very short. And on the other side, the academic office often manages everything in spreadsheets. I experienced this stress myself, and that is exactly why I chose this project.</a:t>
+              <a:t>Let me start with the problem. I am sure that many of you remember registration day. Everyone clicks at the same time, so the seats are gone in a few minutes. It is also easy to choose two classes at the same time by mistake. The registration period is very short, too. And for the university staff, a lot of the work is still done in Excel. I have had this stressful experience myself, and that is why I chose this project.</a:t>
             </a:r>
             <a:endParaRPr lang="en-US" dirty="0"/>
           </a:p>
@@ -1086,7 +1086,7 @@
           <a:p>
             <a:r>
               <a:rPr lang="en-US" dirty="0"/>
-              <a:t>Here is the project at a glance. The system has two portals: one for students and one for administrators. It checks nine rules every time a student signs up for a class. I built it in about three months, from January to March 2026, and I designed and developed it by myself. My main goal was simple: the system must be fair, reliable and easy to use, even on the busiest day.</a:t>
+              <a:t>Here is a quick look at the project. The system has two portals: one for students and one for staff. It checks nine rules every time a student registers for a class. I built it in about three months, from January to March this year, and I did all the work by myself. My main goal was simple: the system must be fair, it must work well, and it must be easy to use, even on the busiest day.</a:t>
             </a:r>
             <a:endParaRPr lang="en-US" dirty="0"/>
           </a:p>
@@ -1174,7 +1174,7 @@
           <a:p>
             <a:r>
               <a:rPr lang="en-US" dirty="0"/>
-              <a:t>Now, let's move on to what the system actually does. Rather than just describing it, I would like to show you some real screenshots. This is the student portal. On the left is the registration page: students can see every class, its timetable and how many seats are left, and they can register or cancel with just one click. On the right, you can see the weekly timetable, which is built automatically, and the grades page with the student's GPA.</a:t>
+              <a:t>Now, let's move on to what the system can do. Instead of just describing it, I would like to show you some real screenshots. This is the student portal. On the left, you can see the registration page. Students can see every class, its timetable and how many seats are left, and they can register or cancel with just one click. On the right, there is the weekly timetable, which is made automatically, and the page where students can check their grades and GPA.</a:t>
             </a:r>
             <a:endParaRPr lang="en-US" dirty="0"/>
           </a:p>
@@ -1262,7 +1262,7 @@
           <a:p>
             <a:r>
               <a:rPr lang="en-US" dirty="0"/>
-              <a:t>And this is the administrator portal. Here, the academic office can open new classes and assign lecturers and rooms. They can also set the registration period for each semester and see the schedule of every room in one view. Each user only sees the portal that matches their role.</a:t>
+              <a:t>And this is the portal for the staff. Here, they can open new classes and choose the lecturer and the room for each class. They can also set the registration period for each semester, and they can see the timetable of every room on one page. Each user can only see the portal which matches their role.</a:t>
             </a:r>
             <a:endParaRPr lang="en-US" dirty="0"/>
           </a:p>
@@ -1350,7 +1350,7 @@
           <a:p>
             <a:r>
               <a:rPr lang="en-US" dirty="0"/>
-              <a:t>So, how does it work? Like most web applications, it has three parts. The front end is what users see in their browser; I built it with React. The back end is the 'brain': it checks who the user is and applies all the rules. And the database stores all the information. Finally, I packaged everything with a tool called Docker, so the whole system can be started with a single command.</a:t>
+              <a:t>So, how does it work? Like most websites, it has three parts. The front end is what users see in their browser. I built it with React. The back end is like the brain of the system. It checks who the user is and follows all the rules. And the database keeps all the information. Finally, I used a tool called Docker, so the whole system can be started with just one command.</a:t>
             </a:r>
             <a:endParaRPr lang="en-US" dirty="0"/>
           </a:p>
@@ -1438,7 +1438,7 @@
           <a:p>
             <a:r>
               <a:rPr lang="en-US" dirty="0"/>
-              <a:t>This brings me to the most interesting part: the challenges. The first one is what I call 'the last seat'. Imagine a class with forty seats and thirty-nine students. Two students click Register at exactly the same moment. Without protection, both see one free seat, both are accepted, and the class ends up with forty-one students. To solve this, I made the sign-up 'all or nothing', and I lock the class for a very short moment, so the second student has to wait. When it is their turn, the system correctly says the class is full. As a final safety net, the database itself refuses more students than seats.</a:t>
+              <a:t>This brings me to the most interesting part: the problems I had to solve. The first one is what I call 'the last seat'. Imagine a class with forty seats, and thirty-nine students have already registered. Then two students click Register at exactly the same time. Without any protection, both of them see one free seat, both of them are accepted, and the class ends up with forty-one students. To fix this, I made the system lock the class for a very short moment, so the second student has to wait. When it is their turn, the system can see that the class is full. As an extra safety rule, the database never allows more students than seats.</a:t>
             </a:r>
             <a:endParaRPr lang="en-US" dirty="0"/>
           </a:p>
@@ -1526,7 +1526,7 @@
           <a:p>
             <a:r>
               <a:rPr lang="en-US" dirty="0"/>
-              <a:t>The second challenge was timetable clashes. It sounds easy, but some classes only meet in odd weeks, and others only in even weeks. So I defined a clear rule: two classes clash only if all three conditions on this slide are true: the same day, overlapping periods, and compatible weeks. And when there is a clash, the system does not just say 'Error'. It tells the student exactly which class is the problem.</a:t>
+              <a:t>The second problem was timetable clashes. It sounds easy, but some classes only meet in odd weeks, and others only meet in even weeks. So I decided on a clear rule: two classes clash only if all three things on this slide are true. They are on the same day, their lesson times overlap, and their weeks match. When there is a clash, the system does not just say 'Error'. It tells the student which class is causing the problem.</a:t>
             </a:r>
             <a:endParaRPr lang="en-US" dirty="0"/>
           </a:p>
@@ -2708,7 +2708,7 @@
                   <a:schemeClr val="tx2"/>
                 </a:solidFill>
               </a:rPr>
-              <a:t>Analysis</a:t>
+              <a:t>Planning</a:t>
             </a:r>
             <a:endParaRPr lang="en-US" sz="1700" dirty="0"/>
           </a:p>
@@ -2744,7 +2744,7 @@
                   <a:schemeClr val="tx1"/>
                 </a:solidFill>
               </a:rPr>
-              <a:t>Studied the real process, wrote the 9 rules</a:t>
+              <a:t>Looked at the real process, wrote 9 rules</a:t>
             </a:r>
             <a:endParaRPr lang="en-US" sz="1300" dirty="0"/>
           </a:p>
@@ -2974,7 +2974,7 @@
                   <a:schemeClr val="tx2"/>
                 </a:solidFill>
               </a:rPr>
-              <a:t>Reorganise</a:t>
+              <a:t>Reorganising</a:t>
             </a:r>
             <a:endParaRPr lang="en-US" sz="1700" dirty="0"/>
           </a:p>
@@ -3240,7 +3240,7 @@
                   <a:schemeClr val="tx2"/>
                 </a:solidFill>
               </a:rPr>
-              <a:t>Release</a:t>
+              <a:t>Sharing</a:t>
             </a:r>
             <a:endParaRPr lang="en-US" sz="1700" dirty="0"/>
           </a:p>
@@ -3276,7 +3276,7 @@
                   <a:schemeClr val="tx1"/>
                 </a:solidFill>
               </a:rPr>
-              <a:t>Docker setup and documentation</a:t>
+              <a:t>Docker setup and guides</a:t>
             </a:r>
             <a:endParaRPr lang="en-US" sz="1300" dirty="0"/>
           </a:p>
@@ -3525,7 +3525,7 @@
                   <a:schemeClr val="tx2"/>
                 </a:solidFill>
               </a:rPr>
-              <a:t>Plan before acting</a:t>
+              <a:t>Plan before doing</a:t>
             </a:r>
             <a:endParaRPr lang="en-US" sz="1700" dirty="0"/>
           </a:p>
@@ -3641,7 +3641,7 @@
                   <a:schemeClr val="tx2"/>
                 </a:solidFill>
               </a:rPr>
-              <a:t>Learn independently</a:t>
+              <a:t>Learn by myself</a:t>
             </a:r>
             <a:endParaRPr lang="en-US" sz="1700" dirty="0"/>
           </a:p>
@@ -3677,7 +3677,7 @@
                   <a:schemeClr val="tx1"/>
                 </a:solidFill>
               </a:rPr>
-              <a:t>I found many answers in English documentation</a:t>
+              <a:t>I found many answers in English guides</a:t>
             </a:r>
             <a:endParaRPr lang="en-US" sz="1400" dirty="0"/>
           </a:p>
@@ -3793,7 +3793,7 @@
                   <a:schemeClr val="tx1"/>
                 </a:solidFill>
               </a:rPr>
-              <a:t>Documentation taught me to explain ideas simply</a:t>
+              <a:t>Writing guides taught me to explain ideas simply</a:t>
             </a:r>
             <a:endParaRPr lang="en-US" sz="1400" dirty="0"/>
           </a:p>
@@ -3909,7 +3909,7 @@
                   <a:schemeClr val="tx1"/>
                 </a:solidFill>
               </a:rPr>
-              <a:t>Small stages kept me motivated and on track</a:t>
+              <a:t>Small stages kept me motivated every week</a:t>
             </a:r>
             <a:endParaRPr lang="en-US" sz="1400" dirty="0"/>
           </a:p>
@@ -4043,7 +4043,7 @@
                   <a:schemeClr val="tx1"/>
                 </a:solidFill>
               </a:rPr>
-              <a:t>Automatic prerequisite check</a:t>
+              <a:t>Check for required courses</a:t>
             </a:r>
             <a:endParaRPr lang="en-US" sz="1500" dirty="0"/>
           </a:p>
@@ -5533,7 +5533,7 @@
                   <a:schemeClr val="tx1"/>
                 </a:solidFill>
               </a:rPr>
-              <a:t>Courses, rooms and sections are often managed in spreadsheets</a:t>
+              <a:t>Staff often manage courses, rooms and classes in Excel</a:t>
             </a:r>
             <a:endParaRPr lang="en-US" sz="1400" dirty="0"/>
           </a:p>
@@ -8565,7 +8565,7 @@
                   <a:schemeClr val="tx1"/>
                 </a:solidFill>
               </a:rPr>
-              <a:t>every check and the sign-up succeed together, or nothing changes</a:t>
+              <a:t>all checks and the sign-up happen together, or nothing is saved</a:t>
             </a:r>
             <a:endParaRPr lang="en-US" sz="1400" dirty="0"/>
           </a:p>
@@ -8665,7 +8665,7 @@
                   <a:schemeClr val="tx1"/>
                 </a:solidFill>
               </a:rPr>
-              <a:t>the database itself refuses more students than seats</a:t>
+              <a:t>the database never allows more students than seats</a:t>
             </a:r>
             <a:endParaRPr lang="en-US" sz="1400" dirty="0"/>
           </a:p>

</xml_diff>